<commit_message>
Lagebild: KI-Lernplattformen und Jahrestagung der didaktischen Leitungen ergänzt
Co-Authored-By: Claude Opus 5.5 <noreply@anthropic.com>
Claude-Session: https://claude.ai/code/session_01KjTLRV2ju5iuSRgoeZgmvB
</commit_message>
<xml_diff>
--- a/technikdidaktisches-kolloquium/praesentationen/TdK_Termin-3_Aktuelle-Entwicklungen-Leistungsbewertung-Referat.pptx
+++ b/technikdidaktisches-kolloquium/praesentationen/TdK_Termin-3_Aktuelle-Entwicklungen-Leistungsbewertung-Referat.pptx
@@ -2790,7 +2790,7 @@
       </p:grpSpPr>
       <p:sp>
         <p:nvSpPr>
-          <p:cNvPr id="2" name="titel-308"/>
+          <p:cNvPr id="2" name="titel-309"/>
           <p:cNvSpPr txBox="1"/>
           <p:nvPr/>
         </p:nvSpPr>
@@ -2826,7 +2826,7 @@
       </p:sp>
       <p:sp>
         <p:nvSpPr>
-          <p:cNvPr id="3" name="quote-309"/>
+          <p:cNvPr id="3" name="quote-310"/>
           <p:cNvSpPr txBox="1"/>
           <p:nvPr/>
         </p:nvSpPr>
@@ -2881,7 +2881,7 @@
       </p:sp>
       <p:sp>
         <p:nvSpPr>
-          <p:cNvPr id="4" name="text-310"/>
+          <p:cNvPr id="4" name="text-311"/>
           <p:cNvSpPr txBox="1"/>
           <p:nvPr/>
         </p:nvSpPr>
@@ -2987,7 +2987,7 @@
       </p:grpSpPr>
       <p:sp>
         <p:nvSpPr>
-          <p:cNvPr id="2" name="titel-311"/>
+          <p:cNvPr id="2" name="titel-312"/>
           <p:cNvSpPr txBox="1"/>
           <p:nvPr/>
         </p:nvSpPr>
@@ -3023,7 +3023,7 @@
       </p:sp>
       <p:sp>
         <p:nvSpPr>
-          <p:cNvPr id="3" name="tile-312"/>
+          <p:cNvPr id="3" name="tile-313"/>
           <p:cNvSpPr txBox="1"/>
           <p:nvPr/>
         </p:nvSpPr>
@@ -3082,7 +3082,7 @@
       </p:sp>
       <p:sp>
         <p:nvSpPr>
-          <p:cNvPr id="4" name="tile-313"/>
+          <p:cNvPr id="4" name="tile-314"/>
           <p:cNvSpPr txBox="1"/>
           <p:nvPr/>
         </p:nvSpPr>
@@ -3141,7 +3141,7 @@
       </p:sp>
       <p:sp>
         <p:nvSpPr>
-          <p:cNvPr id="5" name="tile-314"/>
+          <p:cNvPr id="5" name="tile-315"/>
           <p:cNvSpPr txBox="1"/>
           <p:nvPr/>
         </p:nvSpPr>
@@ -3200,7 +3200,7 @@
       </p:sp>
       <p:sp>
         <p:nvSpPr>
-          <p:cNvPr id="6" name="quote-315"/>
+          <p:cNvPr id="6" name="quote-316"/>
           <p:cNvSpPr txBox="1"/>
           <p:nvPr/>
         </p:nvSpPr>
@@ -3325,7 +3325,7 @@
       </p:grpSpPr>
       <p:sp>
         <p:nvSpPr>
-          <p:cNvPr id="2" name="titel-316"/>
+          <p:cNvPr id="2" name="titel-317"/>
           <p:cNvSpPr txBox="1"/>
           <p:nvPr/>
         </p:nvSpPr>
@@ -3361,7 +3361,7 @@
       </p:sp>
       <p:sp>
         <p:nvSpPr>
-          <p:cNvPr id="3" name="text-317"/>
+          <p:cNvPr id="3" name="text-318"/>
           <p:cNvSpPr txBox="1"/>
           <p:nvPr/>
         </p:nvSpPr>
@@ -3397,7 +3397,7 @@
       </p:sp>
       <p:sp>
         <p:nvSpPr>
-          <p:cNvPr id="4" name="text-318"/>
+          <p:cNvPr id="4" name="text-319"/>
           <p:cNvSpPr txBox="1"/>
           <p:nvPr/>
         </p:nvSpPr>
@@ -3433,7 +3433,7 @@
       </p:sp>
       <p:sp>
         <p:nvSpPr>
-          <p:cNvPr id="5" name="text-319"/>
+          <p:cNvPr id="5" name="text-320"/>
           <p:cNvSpPr txBox="1"/>
           <p:nvPr/>
         </p:nvSpPr>
@@ -3469,7 +3469,7 @@
       </p:sp>
       <p:sp>
         <p:nvSpPr>
-          <p:cNvPr id="6" name="text-320"/>
+          <p:cNvPr id="6" name="text-321"/>
           <p:cNvSpPr txBox="1"/>
           <p:nvPr/>
         </p:nvSpPr>
@@ -3505,7 +3505,7 @@
       </p:sp>
       <p:sp>
         <p:nvSpPr>
-          <p:cNvPr id="7" name="text-321"/>
+          <p:cNvPr id="7" name="text-322"/>
           <p:cNvSpPr txBox="1"/>
           <p:nvPr/>
         </p:nvSpPr>
@@ -3541,7 +3541,7 @@
       </p:sp>
       <p:sp>
         <p:nvSpPr>
-          <p:cNvPr id="8" name="text-322"/>
+          <p:cNvPr id="8" name="text-323"/>
           <p:cNvSpPr txBox="1"/>
           <p:nvPr/>
         </p:nvSpPr>
@@ -3577,7 +3577,7 @@
       </p:sp>
       <p:sp>
         <p:nvSpPr>
-          <p:cNvPr id="9" name="box-323"/>
+          <p:cNvPr id="9" name="box-324"/>
           <p:cNvSpPr txBox="1"/>
           <p:nvPr/>
         </p:nvSpPr>
@@ -3685,7 +3685,7 @@
       </p:grpSpPr>
       <p:sp>
         <p:nvSpPr>
-          <p:cNvPr id="2" name="titel-324"/>
+          <p:cNvPr id="2" name="titel-325"/>
           <p:cNvSpPr txBox="1"/>
           <p:nvPr/>
         </p:nvSpPr>
@@ -3721,7 +3721,7 @@
       </p:sp>
       <p:sp>
         <p:nvSpPr>
-          <p:cNvPr id="3" name="tile-325"/>
+          <p:cNvPr id="3" name="tile-326"/>
           <p:cNvSpPr txBox="1"/>
           <p:nvPr/>
         </p:nvSpPr>
@@ -3780,7 +3780,7 @@
       </p:sp>
       <p:sp>
         <p:nvSpPr>
-          <p:cNvPr id="4" name="tile-326"/>
+          <p:cNvPr id="4" name="tile-327"/>
           <p:cNvSpPr txBox="1"/>
           <p:nvPr/>
         </p:nvSpPr>
@@ -3839,7 +3839,7 @@
       </p:sp>
       <p:sp>
         <p:nvSpPr>
-          <p:cNvPr id="5" name="box-327"/>
+          <p:cNvPr id="5" name="box-328"/>
           <p:cNvSpPr txBox="1"/>
           <p:nvPr/>
         </p:nvSpPr>
@@ -3877,7 +3877,7 @@
       </p:sp>
       <p:sp>
         <p:nvSpPr>
-          <p:cNvPr id="6" name="text-328"/>
+          <p:cNvPr id="6" name="text-329"/>
           <p:cNvSpPr txBox="1"/>
           <p:nvPr/>
         </p:nvSpPr>
@@ -3983,7 +3983,7 @@
       </p:grpSpPr>
       <p:sp>
         <p:nvSpPr>
-          <p:cNvPr id="2" name="titel-329"/>
+          <p:cNvPr id="2" name="titel-330"/>
           <p:cNvSpPr txBox="1"/>
           <p:nvPr/>
         </p:nvSpPr>
@@ -4019,7 +4019,7 @@
       </p:sp>
       <p:sp>
         <p:nvSpPr>
-          <p:cNvPr id="3" name="step-330"/>
+          <p:cNvPr id="3" name="step-331"/>
           <p:cNvSpPr txBox="1"/>
           <p:nvPr/>
         </p:nvSpPr>
@@ -4078,7 +4078,7 @@
       </p:sp>
       <p:sp>
         <p:nvSpPr>
-          <p:cNvPr id="4" name="arrow-331"/>
+          <p:cNvPr id="4" name="arrow-332"/>
           <p:cNvSpPr/>
           <p:nvPr/>
         </p:nvSpPr>
@@ -4102,7 +4102,7 @@
       </p:sp>
       <p:sp>
         <p:nvSpPr>
-          <p:cNvPr id="5" name="step-332"/>
+          <p:cNvPr id="5" name="step-333"/>
           <p:cNvSpPr txBox="1"/>
           <p:nvPr/>
         </p:nvSpPr>
@@ -4161,7 +4161,7 @@
       </p:sp>
       <p:sp>
         <p:nvSpPr>
-          <p:cNvPr id="6" name="arrow-333"/>
+          <p:cNvPr id="6" name="arrow-334"/>
           <p:cNvSpPr/>
           <p:nvPr/>
         </p:nvSpPr>
@@ -4185,7 +4185,7 @@
       </p:sp>
       <p:sp>
         <p:nvSpPr>
-          <p:cNvPr id="7" name="step-334"/>
+          <p:cNvPr id="7" name="step-335"/>
           <p:cNvSpPr txBox="1"/>
           <p:nvPr/>
         </p:nvSpPr>
@@ -4244,7 +4244,7 @@
       </p:sp>
       <p:sp>
         <p:nvSpPr>
-          <p:cNvPr id="8" name="arrow-335"/>
+          <p:cNvPr id="8" name="arrow-336"/>
           <p:cNvSpPr/>
           <p:nvPr/>
         </p:nvSpPr>
@@ -4268,7 +4268,7 @@
       </p:sp>
       <p:sp>
         <p:nvSpPr>
-          <p:cNvPr id="9" name="step-336"/>
+          <p:cNvPr id="9" name="step-337"/>
           <p:cNvSpPr txBox="1"/>
           <p:nvPr/>
         </p:nvSpPr>
@@ -4327,7 +4327,7 @@
       </p:sp>
       <p:sp>
         <p:nvSpPr>
-          <p:cNvPr id="10" name="arrow-337"/>
+          <p:cNvPr id="10" name="arrow-338"/>
           <p:cNvSpPr/>
           <p:nvPr/>
         </p:nvSpPr>
@@ -4351,7 +4351,7 @@
       </p:sp>
       <p:sp>
         <p:nvSpPr>
-          <p:cNvPr id="11" name="step-338"/>
+          <p:cNvPr id="11" name="step-339"/>
           <p:cNvSpPr txBox="1"/>
           <p:nvPr/>
         </p:nvSpPr>
@@ -4410,7 +4410,7 @@
       </p:sp>
       <p:graphicFrame>
         <p:nvGraphicFramePr>
-          <p:cNvPr id="15" name="table-339"/>
+          <p:cNvPr id="15" name="table-340"/>
           <p:cNvGraphicFramePr>
             <a:graphicFrameLocks noGrp="1"/>
           </p:cNvGraphicFramePr>
@@ -5006,7 +5006,7 @@
       </p:grpSpPr>
       <p:sp>
         <p:nvSpPr>
-          <p:cNvPr id="2" name="titel-340"/>
+          <p:cNvPr id="2" name="titel-341"/>
           <p:cNvSpPr txBox="1"/>
           <p:nvPr/>
         </p:nvSpPr>
@@ -5042,7 +5042,7 @@
       </p:sp>
       <p:sp>
         <p:nvSpPr>
-          <p:cNvPr id="3" name="tile-341"/>
+          <p:cNvPr id="3" name="tile-342"/>
           <p:cNvSpPr txBox="1"/>
           <p:nvPr/>
         </p:nvSpPr>
@@ -5101,7 +5101,7 @@
       </p:sp>
       <p:sp>
         <p:nvSpPr>
-          <p:cNvPr id="4" name="tile-342"/>
+          <p:cNvPr id="4" name="tile-343"/>
           <p:cNvSpPr txBox="1"/>
           <p:nvPr/>
         </p:nvSpPr>
@@ -5160,7 +5160,7 @@
       </p:sp>
       <p:sp>
         <p:nvSpPr>
-          <p:cNvPr id="5" name="link-343"/>
+          <p:cNvPr id="5" name="link-344"/>
           <p:cNvSpPr txBox="1"/>
           <p:nvPr/>
         </p:nvSpPr>
@@ -5214,7 +5214,7 @@
       </p:sp>
       <p:pic>
         <p:nvPicPr>
-          <p:cNvPr id="6" name="qr-344" descr="QR-Code zur Kursseite: https://t1p.de/tdk-26">    </p:cNvPr>
+          <p:cNvPr id="6" name="qr-345" descr="QR-Code zur Kursseite: https://t1p.de/tdk-26">    </p:cNvPr>
           <p:cNvPicPr>
             <a:picLocks noChangeAspect="1"/>
           </p:cNvPicPr>
@@ -5855,7 +5855,7 @@
                   <a:srgbClr val="14232F"/>
                 </a:solidFill>
               </a:rPr>
-              <a:t>Netzwerktagung AWT, DGTB</a:t>
+              <a:t>Netzwerktagung AWT, Jahrestagung der didaktischen Leitungen, DGTB</a:t>
             </a:r>
             <a:endParaRPr lang="en-US" sz="2200" dirty="0"/>
           </a:p>
@@ -6094,7 +6094,7 @@
         <p:spPr>
           <a:xfrm>
             <a:off x="548640" y="1600200"/>
-            <a:ext cx="3474720" cy="1920240"/>
+            <a:ext cx="3474720" cy="1828800"/>
           </a:xfrm>
           <a:prstGeom prst="rect">
             <a:avLst/>
@@ -6172,7 +6172,7 @@
         <p:spPr>
           <a:xfrm>
             <a:off x="4297680" y="1600200"/>
-            <a:ext cx="3474720" cy="1920240"/>
+            <a:ext cx="3474720" cy="1828800"/>
           </a:xfrm>
           <a:prstGeom prst="rect">
             <a:avLst/>
@@ -6250,7 +6250,7 @@
         <p:spPr>
           <a:xfrm>
             <a:off x="8046720" y="1600200"/>
-            <a:ext cx="3474720" cy="1920240"/>
+            <a:ext cx="3474720" cy="1828800"/>
           </a:xfrm>
           <a:prstGeom prst="rect">
             <a:avLst/>
@@ -6277,7 +6277,7 @@
                   <a:srgbClr val="035591"/>
                 </a:solidFill>
               </a:rPr>
-              <a:t>Digitalisierung</a:t>
+              <a:t>Curricula &amp; Erlasse</a:t>
             </a:r>
             <a:endParaRPr lang="en-US" sz="2000" dirty="0"/>
           </a:p>
@@ -6295,7 +6295,7 @@
                   <a:srgbClr val="14232F"/>
                 </a:solidFill>
               </a:rPr>
-              <a:t>Nachfrage: Arduino, 3D-Druck, Lasercutter</a:t>
+              <a:t>KC AWT IGS (MK 2023)</a:t>
             </a:r>
             <a:endParaRPr lang="en-US" sz="2000" dirty="0"/>
           </a:p>
@@ -6313,7 +6313,7 @@
                   <a:srgbClr val="14232F"/>
                 </a:solidFill>
               </a:rPr>
-              <a:t>n-21-Projektschulen</a:t>
+              <a:t>IGS-Erlass 2026: Projektunterricht in jedem Jahrgang</a:t>
             </a:r>
             <a:endParaRPr lang="en-US" sz="2000" dirty="0"/>
           </a:p>
@@ -6327,8 +6327,8 @@
         </p:nvSpPr>
         <p:spPr>
           <a:xfrm>
-            <a:off x="548640" y="3703320"/>
-            <a:ext cx="3474720" cy="1920240"/>
+            <a:off x="548640" y="3611880"/>
+            <a:ext cx="2567864" cy="2103120"/>
           </a:xfrm>
           <a:prstGeom prst="rect">
             <a:avLst/>
@@ -6350,14 +6350,14 @@
               <a:buNone/>
             </a:pPr>
             <a:r>
-              <a:rPr lang="en-US" sz="2000" b="1" dirty="0">
+              <a:rPr lang="en-US" sz="1800" b="1" dirty="0">
                 <a:solidFill>
                   <a:srgbClr val="035591"/>
                 </a:solidFill>
               </a:rPr>
-              <a:t>Curricula &amp; Erlasse</a:t>
-            </a:r>
-            <a:endParaRPr lang="en-US" sz="2000" dirty="0"/>
+              <a:t>Digitalisierung</a:t>
+            </a:r>
+            <a:endParaRPr lang="en-US" sz="1800" dirty="0"/>
           </a:p>
           <a:p>
             <a:pPr marL="203200" indent="-203200">
@@ -6368,14 +6368,14 @@
               <a:buChar char="•"/>
             </a:pPr>
             <a:r>
-              <a:rPr lang="en-US" sz="1600" dirty="0">
+              <a:rPr lang="en-US" sz="1500" dirty="0">
                 <a:solidFill>
                   <a:srgbClr val="14232F"/>
                 </a:solidFill>
               </a:rPr>
-              <a:t>KC AWT IGS (MK 2023)</a:t>
-            </a:r>
-            <a:endParaRPr lang="en-US" sz="2000" dirty="0"/>
+              <a:t>Arduino, 3D-Druck, Lasercutter</a:t>
+            </a:r>
+            <a:endParaRPr lang="en-US" sz="1800" dirty="0"/>
           </a:p>
           <a:p>
             <a:pPr marL="203200" indent="-203200">
@@ -6386,14 +6386,14 @@
               <a:buChar char="•"/>
             </a:pPr>
             <a:r>
-              <a:rPr lang="en-US" sz="1600" dirty="0">
+              <a:rPr lang="en-US" sz="1500" dirty="0">
                 <a:solidFill>
                   <a:srgbClr val="14232F"/>
                 </a:solidFill>
               </a:rPr>
-              <a:t>IGS-Erlass 2026: Projektunterricht in jedem Jahrgang</a:t>
-            </a:r>
-            <a:endParaRPr lang="en-US" sz="2000" dirty="0"/>
+              <a:t>n-21-Projektschulen</a:t>
+            </a:r>
+            <a:endParaRPr lang="en-US" sz="1800" dirty="0"/>
           </a:p>
         </p:txBody>
       </p:sp>
@@ -6405,8 +6405,86 @@
         </p:nvSpPr>
         <p:spPr>
           <a:xfrm>
-            <a:off x="4297680" y="3703320"/>
-            <a:ext cx="3474720" cy="1920240"/>
+            <a:off x="3390824" y="3611880"/>
+            <a:ext cx="2567864" cy="2103120"/>
+          </a:xfrm>
+          <a:prstGeom prst="rect">
+            <a:avLst/>
+          </a:prstGeom>
+          <a:solidFill>
+            <a:srgbClr val="E2F4E8"/>
+          </a:solidFill>
+          <a:ln w="6350">
+            <a:solidFill>
+              <a:srgbClr val="E2F4E8"/>
+            </a:solidFill>
+          </a:ln>
+        </p:spPr>
+        <p:txBody>
+          <a:bodyPr wrap="square" lIns="127000" tIns="127000" rIns="127000" bIns="127000" rtlCol="0" anchor="t"/>
+          <a:lstStyle/>
+          <a:p>
+            <a:pPr indent="0" marL="0">
+              <a:buNone/>
+            </a:pPr>
+            <a:r>
+              <a:rPr lang="en-US" sz="1800" b="1" dirty="0">
+                <a:solidFill>
+                  <a:srgbClr val="035591"/>
+                </a:solidFill>
+              </a:rPr>
+              <a:t>KI-Lernplattformen</a:t>
+            </a:r>
+            <a:endParaRPr lang="en-US" sz="1800" dirty="0"/>
+          </a:p>
+          <a:p>
+            <a:pPr marL="203200" indent="-203200">
+              <a:spcBef>
+                <a:spcPts val="400"/>
+              </a:spcBef>
+              <a:buSzPct val="100000"/>
+              <a:buChar char="•"/>
+            </a:pPr>
+            <a:r>
+              <a:rPr lang="en-US" sz="1500" dirty="0">
+                <a:solidFill>
+                  <a:srgbClr val="14232F"/>
+                </a:solidFill>
+              </a:rPr>
+              <a:t>KI-Kompetenz, z. B. AI Badge Jg. 7–9</a:t>
+            </a:r>
+            <a:endParaRPr lang="en-US" sz="1800" dirty="0"/>
+          </a:p>
+          <a:p>
+            <a:pPr marL="203200" indent="-203200">
+              <a:spcBef>
+                <a:spcPts val="400"/>
+              </a:spcBef>
+              <a:buSzPct val="100000"/>
+              <a:buChar char="•"/>
+            </a:pPr>
+            <a:r>
+              <a:rPr lang="en-US" sz="1500" dirty="0">
+                <a:solidFill>
+                  <a:srgbClr val="14232F"/>
+                </a:solidFill>
+              </a:rPr>
+              <a:t>Schul-KI, z. B. fobizz</a:t>
+            </a:r>
+            <a:endParaRPr lang="en-US" sz="1800" dirty="0"/>
+          </a:p>
+        </p:txBody>
+      </p:sp>
+      <p:sp>
+        <p:nvSpPr>
+          <p:cNvPr id="8" name="tile-261"/>
+          <p:cNvSpPr txBox="1"/>
+          <p:nvPr/>
+        </p:nvSpPr>
+        <p:spPr>
+          <a:xfrm>
+            <a:off x="6233008" y="3611880"/>
+            <a:ext cx="2567864" cy="2103120"/>
           </a:xfrm>
           <a:prstGeom prst="rect">
             <a:avLst/>
@@ -6428,14 +6506,14 @@
               <a:buNone/>
             </a:pPr>
             <a:r>
-              <a:rPr lang="en-US" sz="2000" b="1" dirty="0">
+              <a:rPr lang="en-US" sz="1800" b="1" dirty="0">
                 <a:solidFill>
                   <a:srgbClr val="035591"/>
                 </a:solidFill>
               </a:rPr>
               <a:t>MakerSpaces</a:t>
             </a:r>
-            <a:endParaRPr lang="en-US" sz="2000" dirty="0"/>
+            <a:endParaRPr lang="en-US" sz="1800" dirty="0"/>
           </a:p>
           <a:p>
             <a:pPr marL="203200" indent="-203200">
@@ -6446,14 +6524,14 @@
               <a:buChar char="•"/>
             </a:pPr>
             <a:r>
-              <a:rPr lang="en-US" sz="1600" dirty="0">
+              <a:rPr lang="en-US" sz="1500" dirty="0">
                 <a:solidFill>
                   <a:srgbClr val="14232F"/>
                 </a:solidFill>
               </a:rPr>
               <a:t>großes Interesse</a:t>
             </a:r>
-            <a:endParaRPr lang="en-US" sz="2000" dirty="0"/>
+            <a:endParaRPr lang="en-US" sz="1800" dirty="0"/>
           </a:p>
           <a:p>
             <a:pPr marL="203200" indent="-203200">
@@ -6464,27 +6542,27 @@
               <a:buChar char="•"/>
             </a:pPr>
             <a:r>
-              <a:rPr lang="en-US" sz="1600" dirty="0">
+              <a:rPr lang="en-US" sz="1500" dirty="0">
                 <a:solidFill>
                   <a:srgbClr val="14232F"/>
                 </a:solidFill>
               </a:rPr>
               <a:t>oft: erst Geräte, dann Konzept</a:t>
             </a:r>
-            <a:endParaRPr lang="en-US" sz="2000" dirty="0"/>
-          </a:p>
-        </p:txBody>
-      </p:sp>
-      <p:sp>
-        <p:nvSpPr>
-          <p:cNvPr id="8" name="tile-261"/>
+            <a:endParaRPr lang="en-US" sz="1800" dirty="0"/>
+          </a:p>
+        </p:txBody>
+      </p:sp>
+      <p:sp>
+        <p:nvSpPr>
+          <p:cNvPr id="9" name="tile-262"/>
           <p:cNvSpPr txBox="1"/>
           <p:nvPr/>
         </p:nvSpPr>
         <p:spPr>
           <a:xfrm>
-            <a:off x="8046720" y="3703320"/>
-            <a:ext cx="3474720" cy="1920240"/>
+            <a:off x="9075191" y="3611880"/>
+            <a:ext cx="2567864" cy="2103120"/>
           </a:xfrm>
           <a:prstGeom prst="rect">
             <a:avLst/>
@@ -6506,14 +6584,14 @@
               <a:buNone/>
             </a:pPr>
             <a:r>
-              <a:rPr lang="en-US" sz="2000" b="1" dirty="0">
+              <a:rPr lang="en-US" sz="1800" b="1" dirty="0">
                 <a:solidFill>
                   <a:srgbClr val="035591"/>
                 </a:solidFill>
               </a:rPr>
               <a:t>Digitale Lernmaterialien</a:t>
             </a:r>
-            <a:endParaRPr lang="en-US" sz="2000" dirty="0"/>
+            <a:endParaRPr lang="en-US" sz="1800" dirty="0"/>
           </a:p>
           <a:p>
             <a:pPr marL="203200" indent="-203200">
@@ -6524,14 +6602,14 @@
               <a:buChar char="•"/>
             </a:pPr>
             <a:r>
-              <a:rPr lang="en-US" sz="1600" dirty="0">
+              <a:rPr lang="en-US" sz="1500" dirty="0">
                 <a:solidFill>
                   <a:srgbClr val="14232F"/>
                 </a:solidFill>
               </a:rPr>
               <a:t>eigene Plattformen, oft mit KI</a:t>
             </a:r>
-            <a:endParaRPr lang="en-US" sz="2000" dirty="0"/>
+            <a:endParaRPr lang="en-US" sz="1800" dirty="0"/>
           </a:p>
           <a:p>
             <a:pPr marL="203200" indent="-203200">
@@ -6542,20 +6620,20 @@
               <a:buChar char="•"/>
             </a:pPr>
             <a:r>
-              <a:rPr lang="en-US" sz="1600" dirty="0">
+              <a:rPr lang="en-US" sz="1500" dirty="0">
                 <a:solidFill>
                   <a:srgbClr val="14232F"/>
                 </a:solidFill>
               </a:rPr>
               <a:t>Qualität, Lizenz, Datenschutz?</a:t>
             </a:r>
-            <a:endParaRPr lang="en-US" sz="2000" dirty="0"/>
-          </a:p>
-        </p:txBody>
-      </p:sp>
-      <p:sp>
-        <p:nvSpPr>
-          <p:cNvPr id="9" name="text-262"/>
+            <a:endParaRPr lang="en-US" sz="1800" dirty="0"/>
+          </a:p>
+        </p:txBody>
+      </p:sp>
+      <p:sp>
+        <p:nvSpPr>
+          <p:cNvPr id="10" name="text-263"/>
           <p:cNvSpPr txBox="1"/>
           <p:nvPr/>
         </p:nvSpPr>
@@ -6583,7 +6661,7 @@
                   <a:srgbClr val="56687A"/>
                 </a:solidFill>
               </a:rPr>
-              <a:t>Beobachtungen aus Fachberatung und Fachmoderation, Stand WiSe 2024/25; Curricula ergänzt 10/2026 (IGS-Erlass v. 01.08.2026, Nr. 4.3 und 4.5)</a:t>
+              <a:t>Beobachtungen aus Fachberatung und Fachmoderation, Stand WiSe 2024/25; Curricula und KI ergänzt 10/2026 (IGS-Erlass v. 01.08.2026, Nr. 4.3 und 4.5)</a:t>
             </a:r>
             <a:endParaRPr lang="en-US" sz="1100" dirty="0"/>
           </a:p>
@@ -6661,7 +6739,7 @@
       </p:grpSpPr>
       <p:sp>
         <p:nvSpPr>
-          <p:cNvPr id="2" name="titel-263"/>
+          <p:cNvPr id="2" name="titel-264"/>
           <p:cNvSpPr txBox="1"/>
           <p:nvPr/>
         </p:nvSpPr>
@@ -6697,7 +6775,7 @@
       </p:sp>
       <p:graphicFrame>
         <p:nvGraphicFramePr>
-          <p:cNvPr id="6" name="table-264"/>
+          <p:cNvPr id="6" name="table-265"/>
           <p:cNvGraphicFramePr>
             <a:graphicFrameLocks noGrp="1"/>
           </p:cNvGraphicFramePr>
@@ -8015,7 +8093,7 @@
       </p:graphicFrame>
       <p:sp>
         <p:nvSpPr>
-          <p:cNvPr id="4" name="text-265"/>
+          <p:cNvPr id="4" name="text-266"/>
           <p:cNvSpPr txBox="1"/>
           <p:nvPr/>
         </p:nvSpPr>
@@ -8121,7 +8199,7 @@
       </p:grpSpPr>
       <p:sp>
         <p:nvSpPr>
-          <p:cNvPr id="2" name="titel-266"/>
+          <p:cNvPr id="2" name="titel-267"/>
           <p:cNvSpPr txBox="1"/>
           <p:nvPr/>
         </p:nvSpPr>
@@ -8157,7 +8235,7 @@
       </p:sp>
       <p:sp>
         <p:nvSpPr>
-          <p:cNvPr id="3" name="box-267"/>
+          <p:cNvPr id="3" name="box-268"/>
           <p:cNvSpPr txBox="1"/>
           <p:nvPr/>
         </p:nvSpPr>
@@ -8195,7 +8273,7 @@
       </p:sp>
       <p:sp>
         <p:nvSpPr>
-          <p:cNvPr id="4" name="box-268"/>
+          <p:cNvPr id="4" name="box-269"/>
           <p:cNvSpPr txBox="1"/>
           <p:nvPr/>
         </p:nvSpPr>
@@ -8248,7 +8326,7 @@
       </p:sp>
       <p:sp>
         <p:nvSpPr>
-          <p:cNvPr id="5" name="box-269"/>
+          <p:cNvPr id="5" name="box-270"/>
           <p:cNvSpPr txBox="1"/>
           <p:nvPr/>
         </p:nvSpPr>
@@ -8301,7 +8379,7 @@
       </p:sp>
       <p:sp>
         <p:nvSpPr>
-          <p:cNvPr id="6" name="box-270"/>
+          <p:cNvPr id="6" name="box-271"/>
           <p:cNvSpPr txBox="1"/>
           <p:nvPr/>
         </p:nvSpPr>
@@ -8354,7 +8432,7 @@
       </p:sp>
       <p:sp>
         <p:nvSpPr>
-          <p:cNvPr id="7" name="box-271"/>
+          <p:cNvPr id="7" name="box-272"/>
           <p:cNvSpPr txBox="1"/>
           <p:nvPr/>
         </p:nvSpPr>
@@ -8407,7 +8485,7 @@
       </p:sp>
       <p:sp>
         <p:nvSpPr>
-          <p:cNvPr id="8" name="box-272"/>
+          <p:cNvPr id="8" name="box-273"/>
           <p:cNvSpPr txBox="1"/>
           <p:nvPr/>
         </p:nvSpPr>
@@ -8460,7 +8538,7 @@
       </p:sp>
       <p:sp>
         <p:nvSpPr>
-          <p:cNvPr id="9" name="box-273"/>
+          <p:cNvPr id="9" name="box-274"/>
           <p:cNvSpPr txBox="1"/>
           <p:nvPr/>
         </p:nvSpPr>
@@ -8513,7 +8591,7 @@
       </p:sp>
       <p:sp>
         <p:nvSpPr>
-          <p:cNvPr id="10" name="box-274"/>
+          <p:cNvPr id="10" name="box-275"/>
           <p:cNvSpPr txBox="1"/>
           <p:nvPr/>
         </p:nvSpPr>
@@ -8566,7 +8644,7 @@
       </p:sp>
       <p:sp>
         <p:nvSpPr>
-          <p:cNvPr id="11" name="box-275"/>
+          <p:cNvPr id="11" name="box-276"/>
           <p:cNvSpPr txBox="1"/>
           <p:nvPr/>
         </p:nvSpPr>
@@ -8619,7 +8697,7 @@
       </p:sp>
       <p:sp>
         <p:nvSpPr>
-          <p:cNvPr id="12" name="box-276"/>
+          <p:cNvPr id="12" name="box-277"/>
           <p:cNvSpPr txBox="1"/>
           <p:nvPr/>
         </p:nvSpPr>
@@ -8672,7 +8750,7 @@
       </p:sp>
       <p:sp>
         <p:nvSpPr>
-          <p:cNvPr id="13" name="box-277"/>
+          <p:cNvPr id="13" name="box-278"/>
           <p:cNvSpPr txBox="1"/>
           <p:nvPr/>
         </p:nvSpPr>
@@ -8710,7 +8788,7 @@
       </p:sp>
       <p:sp>
         <p:nvSpPr>
-          <p:cNvPr id="14" name="text-278"/>
+          <p:cNvPr id="14" name="text-279"/>
           <p:cNvSpPr txBox="1"/>
           <p:nvPr/>
         </p:nvSpPr>
@@ -8816,7 +8894,7 @@
       </p:grpSpPr>
       <p:sp>
         <p:nvSpPr>
-          <p:cNvPr id="2" name="titel-279"/>
+          <p:cNvPr id="2" name="titel-280"/>
           <p:cNvSpPr txBox="1"/>
           <p:nvPr/>
         </p:nvSpPr>
@@ -8852,7 +8930,7 @@
       </p:sp>
       <p:sp>
         <p:nvSpPr>
-          <p:cNvPr id="3" name="text-280"/>
+          <p:cNvPr id="3" name="text-281"/>
           <p:cNvSpPr txBox="1"/>
           <p:nvPr/>
         </p:nvSpPr>
@@ -8888,7 +8966,7 @@
       </p:sp>
       <p:sp>
         <p:nvSpPr>
-          <p:cNvPr id="4" name="step-281"/>
+          <p:cNvPr id="4" name="step-282"/>
           <p:cNvSpPr txBox="1"/>
           <p:nvPr/>
         </p:nvSpPr>
@@ -8947,7 +9025,7 @@
       </p:sp>
       <p:sp>
         <p:nvSpPr>
-          <p:cNvPr id="5" name="arrow-282"/>
+          <p:cNvPr id="5" name="arrow-283"/>
           <p:cNvSpPr/>
           <p:nvPr/>
         </p:nvSpPr>
@@ -8971,7 +9049,7 @@
       </p:sp>
       <p:sp>
         <p:nvSpPr>
-          <p:cNvPr id="6" name="step-283"/>
+          <p:cNvPr id="6" name="step-284"/>
           <p:cNvSpPr txBox="1"/>
           <p:nvPr/>
         </p:nvSpPr>
@@ -9030,7 +9108,7 @@
       </p:sp>
       <p:sp>
         <p:nvSpPr>
-          <p:cNvPr id="7" name="arrow-284"/>
+          <p:cNvPr id="7" name="arrow-285"/>
           <p:cNvSpPr/>
           <p:nvPr/>
         </p:nvSpPr>
@@ -9054,7 +9132,7 @@
       </p:sp>
       <p:sp>
         <p:nvSpPr>
-          <p:cNvPr id="8" name="step-285"/>
+          <p:cNvPr id="8" name="step-286"/>
           <p:cNvSpPr txBox="1"/>
           <p:nvPr/>
         </p:nvSpPr>
@@ -9113,7 +9191,7 @@
       </p:sp>
       <p:sp>
         <p:nvSpPr>
-          <p:cNvPr id="9" name="arrow-286"/>
+          <p:cNvPr id="9" name="arrow-287"/>
           <p:cNvSpPr/>
           <p:nvPr/>
         </p:nvSpPr>
@@ -9137,7 +9215,7 @@
       </p:sp>
       <p:sp>
         <p:nvSpPr>
-          <p:cNvPr id="10" name="step-287"/>
+          <p:cNvPr id="10" name="step-288"/>
           <p:cNvSpPr txBox="1"/>
           <p:nvPr/>
         </p:nvSpPr>
@@ -9196,7 +9274,7 @@
       </p:sp>
       <p:sp>
         <p:nvSpPr>
-          <p:cNvPr id="11" name="arrow-288"/>
+          <p:cNvPr id="11" name="arrow-289"/>
           <p:cNvSpPr/>
           <p:nvPr/>
         </p:nvSpPr>
@@ -9220,7 +9298,7 @@
       </p:sp>
       <p:sp>
         <p:nvSpPr>
-          <p:cNvPr id="12" name="step-289"/>
+          <p:cNvPr id="12" name="step-290"/>
           <p:cNvSpPr txBox="1"/>
           <p:nvPr/>
         </p:nvSpPr>
@@ -9279,7 +9357,7 @@
       </p:sp>
       <p:sp>
         <p:nvSpPr>
-          <p:cNvPr id="13" name="text-290"/>
+          <p:cNvPr id="13" name="text-291"/>
           <p:cNvSpPr txBox="1"/>
           <p:nvPr/>
         </p:nvSpPr>
@@ -9385,7 +9463,7 @@
       </p:grpSpPr>
       <p:sp>
         <p:nvSpPr>
-          <p:cNvPr id="2" name="titel-291"/>
+          <p:cNvPr id="2" name="titel-292"/>
           <p:cNvSpPr txBox="1"/>
           <p:nvPr/>
         </p:nvSpPr>
@@ -9421,7 +9499,7 @@
       </p:sp>
       <p:sp>
         <p:nvSpPr>
-          <p:cNvPr id="3" name="tile-292"/>
+          <p:cNvPr id="3" name="tile-293"/>
           <p:cNvSpPr txBox="1"/>
           <p:nvPr/>
         </p:nvSpPr>
@@ -9517,7 +9595,7 @@
       </p:sp>
       <p:sp>
         <p:nvSpPr>
-          <p:cNvPr id="4" name="tile-293"/>
+          <p:cNvPr id="4" name="tile-294"/>
           <p:cNvSpPr txBox="1"/>
           <p:nvPr/>
         </p:nvSpPr>
@@ -9613,7 +9691,7 @@
       </p:sp>
       <p:sp>
         <p:nvSpPr>
-          <p:cNvPr id="5" name="text-294"/>
+          <p:cNvPr id="5" name="text-295"/>
           <p:cNvSpPr txBox="1"/>
           <p:nvPr/>
         </p:nvSpPr>
@@ -9719,7 +9797,7 @@
       </p:grpSpPr>
       <p:sp>
         <p:nvSpPr>
-          <p:cNvPr id="2" name="titel-295"/>
+          <p:cNvPr id="2" name="titel-296"/>
           <p:cNvSpPr txBox="1"/>
           <p:nvPr/>
         </p:nvSpPr>
@@ -9755,7 +9833,7 @@
       </p:sp>
       <p:sp>
         <p:nvSpPr>
-          <p:cNvPr id="3" name="box-296"/>
+          <p:cNvPr id="3" name="box-297"/>
           <p:cNvSpPr txBox="1"/>
           <p:nvPr/>
         </p:nvSpPr>
@@ -9793,7 +9871,7 @@
       </p:sp>
       <p:sp>
         <p:nvSpPr>
-          <p:cNvPr id="4" name="box-297"/>
+          <p:cNvPr id="4" name="box-298"/>
           <p:cNvSpPr txBox="1"/>
           <p:nvPr/>
         </p:nvSpPr>
@@ -9831,7 +9909,7 @@
       </p:sp>
       <p:sp>
         <p:nvSpPr>
-          <p:cNvPr id="5" name="box-298"/>
+          <p:cNvPr id="5" name="box-299"/>
           <p:cNvSpPr txBox="1"/>
           <p:nvPr/>
         </p:nvSpPr>
@@ -9869,7 +9947,7 @@
       </p:sp>
       <p:sp>
         <p:nvSpPr>
-          <p:cNvPr id="6" name="box-299"/>
+          <p:cNvPr id="6" name="box-300"/>
           <p:cNvSpPr txBox="1"/>
           <p:nvPr/>
         </p:nvSpPr>
@@ -9907,7 +9985,7 @@
       </p:sp>
       <p:sp>
         <p:nvSpPr>
-          <p:cNvPr id="7" name="box-300"/>
+          <p:cNvPr id="7" name="box-301"/>
           <p:cNvSpPr txBox="1"/>
           <p:nvPr/>
         </p:nvSpPr>
@@ -9945,7 +10023,7 @@
       </p:sp>
       <p:sp>
         <p:nvSpPr>
-          <p:cNvPr id="8" name="box-301"/>
+          <p:cNvPr id="8" name="box-302"/>
           <p:cNvSpPr txBox="1"/>
           <p:nvPr/>
         </p:nvSpPr>
@@ -9983,7 +10061,7 @@
       </p:sp>
       <p:sp>
         <p:nvSpPr>
-          <p:cNvPr id="9" name="box-302"/>
+          <p:cNvPr id="9" name="box-303"/>
           <p:cNvSpPr txBox="1"/>
           <p:nvPr/>
         </p:nvSpPr>
@@ -10021,7 +10099,7 @@
       </p:sp>
       <p:sp>
         <p:nvSpPr>
-          <p:cNvPr id="10" name="box-303"/>
+          <p:cNvPr id="10" name="box-304"/>
           <p:cNvSpPr txBox="1"/>
           <p:nvPr/>
         </p:nvSpPr>
@@ -10059,7 +10137,7 @@
       </p:sp>
       <p:sp>
         <p:nvSpPr>
-          <p:cNvPr id="11" name="box-304"/>
+          <p:cNvPr id="11" name="box-305"/>
           <p:cNvSpPr txBox="1"/>
           <p:nvPr/>
         </p:nvSpPr>
@@ -10097,7 +10175,7 @@
       </p:sp>
       <p:sp>
         <p:nvSpPr>
-          <p:cNvPr id="12" name="box-305"/>
+          <p:cNvPr id="12" name="box-306"/>
           <p:cNvSpPr txBox="1"/>
           <p:nvPr/>
         </p:nvSpPr>
@@ -10135,7 +10213,7 @@
       </p:sp>
       <p:sp>
         <p:nvSpPr>
-          <p:cNvPr id="13" name="box-306"/>
+          <p:cNvPr id="13" name="box-307"/>
           <p:cNvSpPr txBox="1"/>
           <p:nvPr/>
         </p:nvSpPr>
@@ -10173,7 +10251,7 @@
       </p:sp>
       <p:sp>
         <p:nvSpPr>
-          <p:cNvPr id="14" name="box-307"/>
+          <p:cNvPr id="14" name="box-308"/>
           <p:cNvSpPr txBox="1"/>
           <p:nvPr/>
         </p:nvSpPr>

</xml_diff>